<commit_message>
Fix Domain 13: mark TOMP-API as covering Complaints & Support
</commit_message>
<xml_diff>
--- a/wiki/modularization/modularization-options.pptx
+++ b/wiki/modularization/modularization-options.pptx
@@ -13275,12 +13275,12 @@
                     <a:p>
                       <a:pPr algn="ctr"/>
                       <a:r>
-                        <a:rPr sz="1200" b="0" i="0">
-                          <a:solidFill>
-                            <a:srgbClr val="CCCCCC"/>
-                          </a:solidFill>
-                        </a:rPr>
-                        <a:t>—</a:t>
+                        <a:rPr sz="1200" b="1" i="0">
+                          <a:solidFill>
+                            <a:srgbClr val="378644"/>
+                          </a:solidFill>
+                        </a:rPr>
+                        <a:t>✓</a:t>
                       </a:r>
                     </a:p>
                   </a:txBody>

</xml_diff>

<commit_message>
Update modularisation analysis: reflect fixed TOMP-API-MP references and Domain 6 coverage
</commit_message>
<xml_diff>
--- a/wiki/modularization/modularization-options.pptx
+++ b/wiki/modularization/modularization-options.pptx
@@ -12051,12 +12051,12 @@
                     <a:p>
                       <a:pPr algn="ctr"/>
                       <a:r>
-                        <a:rPr sz="1200" b="0" i="0">
-                          <a:solidFill>
-                            <a:srgbClr val="CCCCCC"/>
-                          </a:solidFill>
-                        </a:rPr>
-                        <a:t>—</a:t>
+                        <a:rPr sz="1200" b="1" i="0">
+                          <a:solidFill>
+                            <a:srgbClr val="378644"/>
+                          </a:solidFill>
+                        </a:rPr>
+                        <a:t>✓</a:t>
                       </a:r>
                     </a:p>
                   </a:txBody>

</xml_diff>